<commit_message>
Add parsed literature corpus, CHI applications review, and project files
- Parse 14 new PDFs to markdown in literature/processed/
- Add docs/CHI_Literature_Applications_Review.md: in-depth review of 25 CHI
  papers organized by application type (trends, hotspots vs harmspots,
  victim concentration, intervention evaluation, resource prioritization)
- Add full literature/processed/ corpus (56 markdown files)
- Add legacy root scripts (01_gun_violence_index.R, 06-aggregate_CHI_wts.R)
- Add ebc_targeting_choices/ subproject
- Update .gitignore to exclude *.csv, *.pdf, *.DS_Store
- Update policy documents

Co-Authored-By: Claude Opus 4.6 (1M context) <noreply@anthropic.com>
</commit_message>
<xml_diff>
--- a/policy/NYC_Crime_Harm_Index.pptx
+++ b/policy/NYC_Crime_Harm_Index.pptx
@@ -2321,17 +2321,6 @@
             <a:pPr marL="0" indent="0" algn="ctr">
               <a:buNone/>
             </a:pPr>
-            <a:r>
-              <a:rPr lang="en-US" sz="1500" dirty="0">
-                <a:solidFill>
-                  <a:srgbClr val="FFFFFF"/>
-                </a:solidFill>
-                <a:latin typeface="Helvetica Neue" pitchFamily="34" charset="0"/>
-                <a:ea typeface="Helvetica Neue" pitchFamily="34" charset="-122"/>
-                <a:cs typeface="Helvetica Neue" pitchFamily="34" charset="-120"/>
-              </a:rPr>
-              <a:t>John Hall</a:t>
-            </a:r>
             <a:endParaRPr lang="en-US" sz="1500" dirty="0"/>
           </a:p>
         </p:txBody>
@@ -4039,8 +4028,8 @@
         </p:nvSpPr>
         <p:spPr>
           <a:xfrm>
-            <a:off x="3657600" y="1737360"/>
-            <a:ext cx="2103120" cy="320040"/>
+            <a:off x="3657599" y="1737360"/>
+            <a:ext cx="2185639" cy="320040"/>
           </a:xfrm>
           <a:prstGeom prst="rect">
             <a:avLst/>
@@ -4064,7 +4053,7 @@
                 <a:ea typeface="Helvetica Neue" pitchFamily="34" charset="-122"/>
                 <a:cs typeface="Helvetica Neue" pitchFamily="34" charset="-120"/>
               </a:rPr>
-              <a:t>Avoids Bias</a:t>
+              <a:t>Avoids Sentencing Bias</a:t>
             </a:r>
             <a:endParaRPr lang="en-US" sz="1500" dirty="0"/>
           </a:p>

</xml_diff>